<commit_message>
Slides: sd-10-023 slide 2 keeps "bị ảnh hưởng"
Co-Authored-By: Claude Opus 5.5 <noreply@anthropic.com>
Claude-Session: https://claude.ai/code/session_01TQmrJYLm4GPgtXpQaEk7ey
</commit_message>
<xml_diff>
--- a/system-design-101/vi/lessons/sd-10-023/slides/sd-10-023.pptx
+++ b/system-design-101/vi/lessons/sd-10-023/slides/sd-10-023.pptx
@@ -3216,7 +3216,7 @@
               <a:buNone/>
             </a:pPr>
             <a:r>
-              <a:rPr lang="en-US" sz="3000" dirty="0" spc="-23" kern="0">
+              <a:rPr lang="en-US" sz="3000" dirty="0" spc="2" kern="0">
                 <a:solidFill>
                   <a:srgbClr val="14161C"/>
                 </a:solidFill>
@@ -3224,7 +3224,18 @@
                 <a:ea typeface="Be Vietnam Pro" pitchFamily="34" charset="-122"/>
                 <a:cs typeface="Be Vietnam Pro" pitchFamily="34" charset="-120"/>
               </a:rPr>
-              <a:t>Bắt</a:t>
+              <a:t>Điều</a:t>
+            </a:r>
+            <a:r>
+              <a:rPr lang="en-US" sz="3000" dirty="0" spc="12" kern="0">
+                <a:solidFill>
+                  <a:srgbClr val="14161C"/>
+                </a:solidFill>
+                <a:latin typeface="Be Vietnam Pro" pitchFamily="34" charset="0"/>
+                <a:ea typeface="Be Vietnam Pro" pitchFamily="34" charset="-122"/>
+                <a:cs typeface="Be Vietnam Pro" pitchFamily="34" charset="-120"/>
+              </a:rPr>
+              <a:t> vừa</a:t>
             </a:r>
             <a:r>
               <a:rPr lang="en-US" sz="3000" dirty="0" spc="14" kern="0">
@@ -3235,10 +3246,10 @@
                 <a:ea typeface="Be Vietnam Pro" pitchFamily="34" charset="-122"/>
                 <a:cs typeface="Be Vietnam Pro" pitchFamily="34" charset="-120"/>
               </a:rPr>
-              <a:t> đầu</a:t>
-            </a:r>
-            <a:r>
-              <a:rPr lang="en-US" sz="3000" dirty="0" spc="-2" kern="0">
+              <a:t> đổi,</a:t>
+            </a:r>
+            <a:r>
+              <a:rPr lang="en-US" sz="3000" dirty="0" spc="-20" kern="0">
                 <a:solidFill>
                   <a:srgbClr val="14161C"/>
                 </a:solidFill>
@@ -3246,7 +3257,7 @@
                 <a:ea typeface="Be Vietnam Pro" pitchFamily="34" charset="-122"/>
                 <a:cs typeface="Be Vietnam Pro" pitchFamily="34" charset="-120"/>
               </a:rPr>
-              <a:t> từ</a:t>
+              <a:t> và</a:t>
             </a:r>
             <a:r>
               <a:rPr lang="en-US" sz="3000" dirty="0" spc="25" kern="0">
@@ -3260,7 +3271,7 @@
               <a:t> điều</a:t>
             </a:r>
             <a:r>
-              <a:rPr lang="en-US" sz="3000" dirty="0" spc="13" kern="0">
+              <a:rPr lang="en-US" sz="3000" dirty="0" spc="3" kern="0">
                 <a:solidFill>
                   <a:srgbClr val="14161C"/>
                 </a:solidFill>
@@ -3268,10 +3279,10 @@
                 <a:ea typeface="Be Vietnam Pro" pitchFamily="34" charset="-122"/>
                 <a:cs typeface="Be Vietnam Pro" pitchFamily="34" charset="-120"/>
               </a:rPr>
-              <a:t> vừa đổi,</a:t>
-            </a:r>
-            <a:r>
-              <a:rPr lang="en-US" sz="3000" dirty="0" spc="26" kern="0">
+              <a:t> có</a:t>
+            </a:r>
+            <a:r>
+              <a:rPr lang="en-US" sz="3000" dirty="0" spc="0" kern="0">
                 <a:solidFill>
                   <a:srgbClr val="14161C"/>
                 </a:solidFill>
@@ -3279,10 +3290,10 @@
                 <a:ea typeface="Be Vietnam Pro" pitchFamily="34" charset="-122"/>
                 <a:cs typeface="Be Vietnam Pro" pitchFamily="34" charset="-120"/>
               </a:rPr>
-              <a:t> điều</a:t>
-            </a:r>
-            <a:r>
-              <a:rPr lang="en-US" sz="3000" dirty="0" spc="3" kern="0">
+              <a:t> thể</a:t>
+            </a:r>
+            <a:r>
+              <a:rPr lang="en-US" sz="3000" dirty="0" spc="4" kern="0">
                 <a:solidFill>
                   <a:srgbClr val="14161C"/>
                 </a:solidFill>
@@ -3290,18 +3301,7 @@
                 <a:ea typeface="Be Vietnam Pro" pitchFamily="34" charset="-122"/>
                 <a:cs typeface="Be Vietnam Pro" pitchFamily="34" charset="-120"/>
               </a:rPr>
-              <a:t> có</a:t>
-            </a:r>
-            <a:r>
-              <a:rPr lang="en-US" sz="3000" dirty="0" spc="0" kern="0">
-                <a:solidFill>
-                  <a:srgbClr val="14161C"/>
-                </a:solidFill>
-                <a:latin typeface="Be Vietnam Pro" pitchFamily="34" charset="0"/>
-                <a:ea typeface="Be Vietnam Pro" pitchFamily="34" charset="-122"/>
-                <a:cs typeface="Be Vietnam Pro" pitchFamily="34" charset="-120"/>
-              </a:rPr>
-              <a:t> thể</a:t>
+              <a:t> bị</a:t>
             </a:r>
             <a:r>
               <a:rPr lang="en-US" sz="3000" dirty="0" spc="-2" kern="0">

</xml_diff>

<commit_message>
Slides: sd-10-023 cover label SYSTEM DESIGN 101 · BÀI 23
Co-Authored-By: Claude Opus 5.5 <noreply@anthropic.com>
Claude-Session: https://claude.ai/code/session_01TQmrJYLm4GPgtXpQaEk7ey
</commit_message>
<xml_diff>
--- a/system-design-101/vi/lessons/sd-10-023/slides/sd-10-023.pptx
+++ b/system-design-101/vi/lessons/sd-10-023/slides/sd-10-023.pptx
@@ -1623,7 +1623,7 @@
               <a:buNone/>
             </a:pPr>
             <a:r>
-              <a:rPr lang="en-US" sz="1950" b="1" spc="216" kern="0" dirty="0">
+              <a:rPr lang="en-US" sz="1950" b="1" spc="197" kern="0" dirty="0">
                 <a:solidFill>
                   <a:srgbClr val="9A978F"/>
                 </a:solidFill>
@@ -1631,7 +1631,29 @@
                 <a:ea typeface="Be Vietnam Pro" pitchFamily="34" charset="-122"/>
                 <a:cs typeface="Be Vietnam Pro" pitchFamily="34" charset="-120"/>
               </a:rPr>
-              <a:t>system-design-101</a:t>
+              <a:t>SYSTEM</a:t>
+            </a:r>
+            <a:r>
+              <a:rPr lang="en-US" sz="1950" b="1" spc="224" kern="0" dirty="0">
+                <a:solidFill>
+                  <a:srgbClr val="9A978F"/>
+                </a:solidFill>
+                <a:latin typeface="Be Vietnam Pro" pitchFamily="34" charset="0"/>
+                <a:ea typeface="Be Vietnam Pro" pitchFamily="34" charset="-122"/>
+                <a:cs typeface="Be Vietnam Pro" pitchFamily="34" charset="-120"/>
+              </a:rPr>
+              <a:t> DESIGN</a:t>
+            </a:r>
+            <a:r>
+              <a:rPr lang="en-US" sz="1950" b="1" spc="227" kern="0" dirty="0">
+                <a:solidFill>
+                  <a:srgbClr val="9A978F"/>
+                </a:solidFill>
+                <a:latin typeface="Be Vietnam Pro" pitchFamily="34" charset="0"/>
+                <a:ea typeface="Be Vietnam Pro" pitchFamily="34" charset="-122"/>
+                <a:cs typeface="Be Vietnam Pro" pitchFamily="34" charset="-120"/>
+              </a:rPr>
+              <a:t> 101</a:t>
             </a:r>
             <a:r>
               <a:rPr lang="en-US" sz="1950" b="1" spc="222" kern="0" dirty="0">
@@ -1645,7 +1667,7 @@
               <a:t> ·</a:t>
             </a:r>
             <a:r>
-              <a:rPr lang="en-US" sz="1950" b="1" spc="219" kern="0" dirty="0">
+              <a:rPr lang="en-US" sz="1950" b="1" spc="220" kern="0" dirty="0">
                 <a:solidFill>
                   <a:srgbClr val="9A978F"/>
                 </a:solidFill>
@@ -1653,10 +1675,10 @@
                 <a:ea typeface="Be Vietnam Pro" pitchFamily="34" charset="-122"/>
                 <a:cs typeface="Be Vietnam Pro" pitchFamily="34" charset="-120"/>
               </a:rPr>
-              <a:t> nhóm</a:t>
-            </a:r>
-            <a:r>
-              <a:rPr lang="en-US" sz="1950" b="1" spc="220" kern="0" dirty="0">
+              <a:t> BÀI</a:t>
+            </a:r>
+            <a:r>
+              <a:rPr lang="en-US" sz="1950" b="1" spc="223" kern="0" dirty="0">
                 <a:solidFill>
                   <a:srgbClr val="9A978F"/>
                 </a:solidFill>
@@ -1664,40 +1686,7 @@
                 <a:ea typeface="Be Vietnam Pro" pitchFamily="34" charset="-122"/>
                 <a:cs typeface="Be Vietnam Pro" pitchFamily="34" charset="-120"/>
               </a:rPr>
-              <a:t> Phát</a:t>
-            </a:r>
-            <a:r>
-              <a:rPr lang="en-US" sz="1950" b="1" spc="230" kern="0" dirty="0">
-                <a:solidFill>
-                  <a:srgbClr val="9A978F"/>
-                </a:solidFill>
-                <a:latin typeface="Be Vietnam Pro" pitchFamily="34" charset="0"/>
-                <a:ea typeface="Be Vietnam Pro" pitchFamily="34" charset="-122"/>
-                <a:cs typeface="Be Vietnam Pro" pitchFamily="34" charset="-120"/>
-              </a:rPr>
-              <a:t> triển</a:t>
-            </a:r>
-            <a:r>
-              <a:rPr lang="en-US" sz="1950" b="1" spc="223" kern="0" dirty="0">
-                <a:solidFill>
-                  <a:srgbClr val="9A978F"/>
-                </a:solidFill>
-                <a:latin typeface="Be Vietnam Pro" pitchFamily="34" charset="0"/>
-                <a:ea typeface="Be Vietnam Pro" pitchFamily="34" charset="-122"/>
-                <a:cs typeface="Be Vietnam Pro" pitchFamily="34" charset="-120"/>
-              </a:rPr>
-              <a:t> phần</a:t>
-            </a:r>
-            <a:r>
-              <a:rPr lang="en-US" sz="1950" b="1" spc="219" kern="0" dirty="0">
-                <a:solidFill>
-                  <a:srgbClr val="9A978F"/>
-                </a:solidFill>
-                <a:latin typeface="Be Vietnam Pro" pitchFamily="34" charset="0"/>
-                <a:ea typeface="Be Vietnam Pro" pitchFamily="34" charset="-122"/>
-                <a:cs typeface="Be Vietnam Pro" pitchFamily="34" charset="-120"/>
-              </a:rPr>
-              <a:t> mềm</a:t>
+              <a:t> 23</a:t>
             </a:r>
             <a:endParaRPr lang="en-US" sz="1950" dirty="0"/>
           </a:p>

</xml_diff>